<commit_message>
docs: link the public website (scopeguard-ai-shield.lovable.app)
README, final status, demo/pitch scripts and the closing slide now point to the live site and repo;
deck rebuilt, re-rendered and re-reviewed. Adds the Lovable site brief used to build the site.

Co-Authored-By: Claude Opus 5.5 <noreply@anthropic.com>
</commit_message>
<xml_diff>
--- a/pitch/ScopeGuard_Pitch.pptx
+++ b/pitch/ScopeGuard_Pitch.pptx
@@ -114,26 +114,26 @@
   <p:extLst>
     <p:ext uri="{521415D9-36F7-43E2-AB2F-B90AF26B5E84}">
       <p14:sectionLst xmlns:p14="http://schemas.microsoft.com/office/powerpoint/2010/main">
-        <p14:section name="Hook" id="{fe9c9326-4621-a85a-7fd8-6f507b953578}">
+        <p14:section name="Hook" id="{2c7a76e0-5ead-0c1a-302f-657928887fc1}">
           <p14:sldIdLst>
             <p14:sldId id="256"/>
           </p14:sldIdLst>
         </p14:section>
-        <p14:section name="Problem and solution" id="{7894511e-a026-e83d-9824-e4e1df353ddd}">
+        <p14:section name="Problem and solution" id="{b66896a2-12d7-3af0-fd7c-3e36679b9cde}">
           <p14:sldIdLst>
             <p14:sldId id="257"/>
             <p14:sldId id="258"/>
             <p14:sldId id="259"/>
           </p14:sldIdLst>
         </p14:section>
-        <p14:section name="Proof" id="{ab0570ba-1881-71ad-6754-d234dd83c088}">
+        <p14:section name="Proof" id="{7a9e2a2a-855e-0dd1-8a92-6f799277f068}">
           <p14:sldIdLst>
             <p14:sldId id="260"/>
             <p14:sldId id="261"/>
             <p14:sldId id="262"/>
           </p14:sldIdLst>
         </p14:section>
-        <p14:section name="Close" id="{0cf1b12a-394e-adf7-79cd-9ec93381daf2}">
+        <p14:section name="Close" id="{c5613f09-2546-33fe-b07a-699b96faf890}">
           <p14:sldIdLst>
             <p14:sldId id="263"/>
           </p14:sldIdLst>
@@ -1524,7 +1524,7 @@
             <a:r>
               <a:rPr lang="en-US" dirty="0"/>
               <a:t>[3:20–3:40] Intended users, not customers: we claim no users, savings or partners. Roadmap items are not implemented.
-Close with the line on the slide, then invite questions. No public repository URL is shown because none is published yet.</a:t>
+Close with the line on the slide, then invite questions. Point at the links: the public website (https://scopeguard-ai-shield.lovable.app/) and the code (https://github.com/Ani-Bliadze/scopeguard).</a:t>
             </a:r>
             <a:endParaRPr lang="en-US" dirty="0"/>
           </a:p>
@@ -12012,14 +12012,14 @@
       </p:sp>
       <p:sp>
         <p:nvSpPr>
-          <p:cNvPr id="36" name="Text 30"/>
-          <p:cNvSpPr txBox="1"/>
-          <p:nvPr/>
-        </p:nvSpPr>
-        <p:spPr>
-          <a:xfrm>
-            <a:off x="548640" y="4526280"/>
-            <a:ext cx="11091672" cy="365760"/>
+          <p:cNvPr id="36" name="links"/>
+          <p:cNvSpPr txBox="1"/>
+          <p:nvPr/>
+        </p:nvSpPr>
+        <p:spPr>
+          <a:xfrm>
+            <a:off x="548640" y="4498848"/>
+            <a:ext cx="11091672" cy="411480"/>
           </a:xfrm>
           <a:prstGeom prst="rect">
             <a:avLst/>
@@ -12035,14 +12035,61 @@
               <a:buNone/>
             </a:pPr>
             <a:r>
-              <a:rPr lang="en-US" sz="1400" dirty="0">
+              <a:rPr lang="en-US" sz="1800" dirty="0">
                 <a:solidFill>
                   <a:schemeClr val="bg2"/>
                 </a:solidFill>
               </a:rPr>
-              <a:t>ScopeGuard · Agent Consent Studio · built and measured in one hackathon day</a:t>
-            </a:r>
-            <a:endParaRPr lang="en-US" sz="1400" dirty="0"/>
+              <a:t>Website  </a:t>
+            </a:r>
+            <a:pPr indent="0" marL="0">
+              <a:buNone/>
+            </a:pPr>
+            <a:r>
+              <a:rPr lang="en-US" sz="1800" u="sng" dirty="0">
+                <a:solidFill>
+                  <a:schemeClr val="accent4"/>
+                </a:solidFill>
+                <a:hlinkClick r:id="rId5" invalidUrl="" action="" tgtFrame="" tooltip="" history="1" highlightClick="0" endSnd="0">
+                  <a:extLst>
+                    <a:ext uri="{A12FA001-AC4F-418D-AE19-62706E023703}">
+                      <ahyp:hlinkClr xmlns:ahyp="http://schemas.microsoft.com/office/drawing/2018/hyperlinkcolor" val="tx"/>
+                    </a:ext>
+                  </a:extLst>
+                </a:hlinkClick>
+              </a:rPr>
+              <a:t>scopeguard-ai-shield.lovable.app</a:t>
+            </a:r>
+            <a:pPr indent="0" marL="0">
+              <a:buNone/>
+            </a:pPr>
+            <a:r>
+              <a:rPr lang="en-US" sz="1800" dirty="0">
+                <a:solidFill>
+                  <a:schemeClr val="bg2"/>
+                </a:solidFill>
+              </a:rPr>
+              <a:t>     Code  </a:t>
+            </a:r>
+            <a:pPr indent="0" marL="0">
+              <a:buNone/>
+            </a:pPr>
+            <a:r>
+              <a:rPr lang="en-US" sz="1800" u="sng" dirty="0">
+                <a:solidFill>
+                  <a:schemeClr val="accent4"/>
+                </a:solidFill>
+                <a:hlinkClick r:id="rId6" invalidUrl="" action="" tgtFrame="" tooltip="" history="1" highlightClick="0" endSnd="0">
+                  <a:extLst>
+                    <a:ext uri="{A12FA001-AC4F-418D-AE19-62706E023703}">
+                      <ahyp:hlinkClr xmlns:ahyp="http://schemas.microsoft.com/office/drawing/2018/hyperlinkcolor" val="tx"/>
+                    </a:ext>
+                  </a:extLst>
+                </a:hlinkClick>
+              </a:rPr>
+              <a:t>github.com/Ani-Bliadze/scopeguard</a:t>
+            </a:r>
+            <a:endParaRPr lang="en-US" sz="1800" dirty="0"/>
           </a:p>
         </p:txBody>
       </p:sp>

</xml_diff>